<commit_message>
omx(team): auto-checkpoint worker-1 [1]
</commit_message>
<xml_diff>
--- a/poc/tasks/annotated_layout_repair_deck/artifacts/gold/final.pptx
+++ b/poc/tasks/annotated_layout_repair_deck/artifacts/gold/final.pptx
@@ -3568,8 +3568,8 @@
         </p:nvCxnSpPr>
         <p:spPr>
           <a:xfrm flipV="1">
-            <a:off x="868680" y="3886200"/>
-            <a:ext cx="685800" cy="548640"/>
+            <a:off x="868680" y="4160520"/>
+            <a:ext cx="685800" cy="365760"/>
           </a:xfrm>
           <a:prstGeom prst="line">
             <a:avLst/>
@@ -3603,8 +3603,8 @@
         </p:nvCxnSpPr>
         <p:spPr>
           <a:xfrm>
-            <a:off x="1554480" y="3886200"/>
-            <a:ext cx="731520" cy="228600"/>
+            <a:off x="1554480" y="4160520"/>
+            <a:ext cx="731520" cy="182880"/>
           </a:xfrm>
           <a:prstGeom prst="line">
             <a:avLst/>
@@ -3638,8 +3638,8 @@
         </p:nvCxnSpPr>
         <p:spPr>
           <a:xfrm flipV="1">
-            <a:off x="2286000" y="3337560"/>
-            <a:ext cx="731520" cy="777240"/>
+            <a:off x="2286000" y="3931920"/>
+            <a:ext cx="731520" cy="411480"/>
           </a:xfrm>
           <a:prstGeom prst="line">
             <a:avLst/>
@@ -3673,8 +3673,8 @@
         </p:nvCxnSpPr>
         <p:spPr>
           <a:xfrm>
-            <a:off x="3017520" y="3337560"/>
-            <a:ext cx="822960" cy="274320"/>
+            <a:off x="3017520" y="3931920"/>
+            <a:ext cx="822960" cy="228600"/>
           </a:xfrm>
           <a:prstGeom prst="line">
             <a:avLst/>
@@ -3708,8 +3708,8 @@
         </p:nvCxnSpPr>
         <p:spPr>
           <a:xfrm flipV="1">
-            <a:off x="3840480" y="2788920"/>
-            <a:ext cx="1325880" cy="822960"/>
+            <a:off x="3840480" y="3703320"/>
+            <a:ext cx="1325880" cy="457200"/>
           </a:xfrm>
           <a:prstGeom prst="line">
             <a:avLst/>

</xml_diff>